<commit_message>
Corrige l'orthographe du nom du porteur du projet
Birima Gueye, et non Birama Gueuye. Corrige les trois supports :
dossier HTML, PDF et presentation PowerPoint.

Co-Authored-By: Claude Opus 5 <noreply@anthropic.com>
Claude-Session: https://claude.ai/code/session_01Sk2VkMjAsq94LgCw4mRKek
</commit_message>
<xml_diff>
--- a/public/documents/presentation-salaatu-alaa-nabii.pptx
+++ b/public/documents/presentation-salaatu-alaa-nabii.pptx
@@ -2877,7 +2877,7 @@
                 <a:ea typeface="Calibri" pitchFamily="34" charset="-122"/>
                 <a:cs typeface="Calibri" pitchFamily="34" charset="-120"/>
               </a:rPr>
-              <a:t>Porteur du projet : Birama Gueuye     ·     Réalisation : Khadim Fall — Cosmos Studio</a:t>
+              <a:t>Porteur du projet : Birima Gueye     ·     Réalisation : Khadim Fall — Cosmos Studio</a:t>
             </a:r>
             <a:endParaRPr lang="en-US" sz="1200" dirty="0"/>
           </a:p>
@@ -5795,7 +5795,7 @@
                 <a:ea typeface="Cambria" pitchFamily="34" charset="-122"/>
                 <a:cs typeface="Cambria" pitchFamily="34" charset="-120"/>
               </a:rPr>
-              <a:t>Birama Gueuye</a:t>
+              <a:t>Birima Gueye</a:t>
             </a:r>
             <a:endParaRPr lang="en-US" sz="1600" dirty="0"/>
           </a:p>
@@ -6790,7 +6790,7 @@
                 <a:ea typeface="Cambria" pitchFamily="34" charset="-122"/>
                 <a:cs typeface="Cambria" pitchFamily="34" charset="-120"/>
               </a:rPr>
-              <a:t>Birama Gueuye</a:t>
+              <a:t>Birima Gueye</a:t>
             </a:r>
             <a:endParaRPr lang="en-US" sz="1600" dirty="0"/>
           </a:p>

</xml_diff>

<commit_message>
Aligne le budget sur 500 000 FCFA exactement
Les postes totalisaient 520 000 alors que le financement recherche etait
annonce a 500 000. Rééquilibrage des postes pour tomber juste :
montage 145 000, tournage 115 000, son et lumiere 45 000, communication
15 000 ; les autres postes sont inchanges. Total 500 000, parts entieres
de 2 a 29 %.

Supprime en consequence la double annonce 520 000 / 500 000 dans les
trois supports, et aligne le mecenat integral sur 500 000.

Co-Authored-By: Claude Opus 5 <noreply@anthropic.com>
Claude-Session: https://claude.ai/code/session_01Sk2VkMjAsq94LgCw4mRKek
</commit_message>
<xml_diff>
--- a/public/documents/presentation-salaatu-alaa-nabii.pptx
+++ b/public/documents/presentation-salaatu-alaa-nabii.pptx
@@ -247,22 +247,22 @@
                   <c:v>10</c:v>
                 </c:pt>
                 <c:pt idx="1">
-                  <c:v>20</c:v>
+                  <c:v>15</c:v>
                 </c:pt>
                 <c:pt idx="2">
-                  <c:v>50</c:v>
+                  <c:v>45</c:v>
                 </c:pt>
                 <c:pt idx="3">
                   <c:v>50</c:v>
                 </c:pt>
                 <c:pt idx="4">
-                  <c:v>120</c:v>
+                  <c:v>115</c:v>
                 </c:pt>
                 <c:pt idx="5">
                   <c:v>120</c:v>
                 </c:pt>
                 <c:pt idx="6">
-                  <c:v>150</c:v>
+                  <c:v>145</c:v>
                 </c:pt>
               </c:numCache>
             </c:numRef>
@@ -343,7 +343,7 @@
         <c:axId val="2094734552"/>
         <c:scaling>
           <c:orientation val="minMax"/>
-          <c:max val="175"/>
+          <c:max val="160"/>
         </c:scaling>
         <c:delete val="0"/>
         <c:axPos val="b"/>
@@ -985,7 +985,7 @@
           <a:p>
             <a:r>
               <a:rPr lang="en-US" dirty="0"/>
-              <a:t>Les 20 000 FCFA d'écart entre 520 000 et 500 000 correspondent à la communication et à la marge, pris en charge par la Dahira.</a:t>
+              <a:t>Les trois premiers postes — montage, déplacements, tournage — représentent 76 % du budget. Ce sont eux qui déterminent le nombre d'intervenants que le film pourra aller rencontrer.</a:t>
             </a:r>
             <a:endParaRPr lang="en-US" dirty="0"/>
           </a:p>
@@ -2694,7 +2694,7 @@
                 <a:ea typeface="Cambria" pitchFamily="34" charset="-122"/>
                 <a:cs typeface="Cambria" pitchFamily="34" charset="-120"/>
               </a:rPr>
-              <a:t>520 000 FCFA</a:t>
+              <a:t>500 000 FCFA</a:t>
             </a:r>
             <a:endParaRPr lang="en-US" sz="1600" dirty="0"/>
           </a:p>
@@ -2733,7 +2733,7 @@
                 <a:ea typeface="Calibri" pitchFamily="34" charset="-122"/>
                 <a:cs typeface="Calibri" pitchFamily="34" charset="-120"/>
               </a:rPr>
-              <a:t>Budget prévisionnel</a:t>
+              <a:t>Budget, intégralement recherché</a:t>
             </a:r>
             <a:endParaRPr lang="en-US" sz="1100" dirty="0"/>
           </a:p>
@@ -2799,7 +2799,7 @@
                 <a:ea typeface="Cambria" pitchFamily="34" charset="-122"/>
                 <a:cs typeface="Cambria" pitchFamily="34" charset="-120"/>
               </a:rPr>
-              <a:t>500 000 FCFA</a:t>
+              <a:t>26–40 MIN</a:t>
             </a:r>
             <a:endParaRPr lang="en-US" sz="1600" dirty="0"/>
           </a:p>
@@ -2838,7 +2838,7 @@
                 <a:ea typeface="Calibri" pitchFamily="34" charset="-122"/>
                 <a:cs typeface="Calibri" pitchFamily="34" charset="-120"/>
               </a:rPr>
-              <a:t>Financement recherché</a:t>
+              <a:t>Documentaire + capsules</a:t>
             </a:r>
             <a:endParaRPr lang="en-US" sz="1100" dirty="0"/>
           </a:p>
@@ -4139,7 +4139,7 @@
                 <a:ea typeface="Cambria" pitchFamily="34" charset="-122"/>
                 <a:cs typeface="Cambria" pitchFamily="34" charset="-120"/>
               </a:rPr>
-              <a:t>520 000 FCFA</a:t>
+              <a:t>500 000 FCFA</a:t>
             </a:r>
             <a:endParaRPr lang="en-US" sz="1900" dirty="0"/>
           </a:p>
@@ -4178,7 +4178,7 @@
                 <a:ea typeface="Calibri" pitchFamily="34" charset="-122"/>
                 <a:cs typeface="Calibri" pitchFamily="34" charset="-120"/>
               </a:rPr>
-              <a:t>Budget total prévisionnel</a:t>
+              <a:t>Budget total, intégralement recherché</a:t>
             </a:r>
             <a:endParaRPr lang="en-US" sz="1100" dirty="0"/>
           </a:p>
@@ -4244,7 +4244,7 @@
                 <a:ea typeface="Cambria" pitchFamily="34" charset="-122"/>
                 <a:cs typeface="Cambria" pitchFamily="34" charset="-120"/>
               </a:rPr>
-              <a:t>500 000 FCFA</a:t>
+              <a:t>145 000 FCFA</a:t>
             </a:r>
             <a:endParaRPr lang="en-US" sz="1900" dirty="0"/>
           </a:p>
@@ -4283,7 +4283,7 @@
                 <a:ea typeface="Calibri" pitchFamily="34" charset="-122"/>
                 <a:cs typeface="Calibri" pitchFamily="34" charset="-120"/>
               </a:rPr>
-              <a:t>Recherchés auprès de partenaires</a:t>
+              <a:t>Poste le plus lourd : le montage</a:t>
             </a:r>
             <a:endParaRPr lang="en-US" sz="1100" dirty="0"/>
           </a:p>
@@ -4349,7 +4349,7 @@
                 <a:ea typeface="Cambria" pitchFamily="34" charset="-122"/>
                 <a:cs typeface="Cambria" pitchFamily="34" charset="-120"/>
               </a:rPr>
-              <a:t>75 %</a:t>
+              <a:t>76 %</a:t>
             </a:r>
             <a:endParaRPr lang="en-US" sz="1900" dirty="0"/>
           </a:p>
@@ -4430,7 +4430,7 @@
                 <a:ea typeface="Calibri" pitchFamily="34" charset="-122"/>
                 <a:cs typeface="Calibri" pitchFamily="34" charset="-120"/>
               </a:rPr>
-              <a:t>Montant prévisionnel, ajustable selon le nombre d'intervenants, les villes de tournage et les besoins techniques définitifs. Toute contribution supplémentaire ira en priorité aux déplacements, qui conditionnent le nombre d'intervenants accessibles.</a:t>
+              <a:t>Chaque poste est chiffré au plus juste : il n'y a pas de dépense de confort dans ce budget. Toute contribution supplémentaire ira en priorité aux déplacements, qui conditionnent le nombre d'intervenants accessibles.</a:t>
             </a:r>
             <a:endParaRPr lang="en-US" sz="1100" dirty="0"/>
           </a:p>
@@ -5392,7 +5392,7 @@
                 <a:ea typeface="Cambria" pitchFamily="34" charset="-122"/>
                 <a:cs typeface="Cambria" pitchFamily="34" charset="-120"/>
               </a:rPr>
-              <a:t>520 000</a:t>
+              <a:t>500 000</a:t>
             </a:r>
             <a:endParaRPr lang="en-US" sz="2400" dirty="0"/>
           </a:p>
@@ -7674,7 +7674,7 @@
                 <a:ea typeface="Cambria" pitchFamily="34" charset="-122"/>
                 <a:cs typeface="Cambria" pitchFamily="34" charset="-120"/>
               </a:rPr>
-              <a:t>520 000</a:t>
+              <a:t>500 000</a:t>
             </a:r>
             <a:endParaRPr lang="en-US" sz="2600" dirty="0"/>
           </a:p>
@@ -7713,7 +7713,7 @@
                 <a:ea typeface="Calibri" pitchFamily="34" charset="-122"/>
                 <a:cs typeface="Calibri" pitchFamily="34" charset="-120"/>
               </a:rPr>
-              <a:t>Budget total, en FCFA</a:t>
+              <a:t>Budget, en FCFA</a:t>
             </a:r>
             <a:endParaRPr lang="en-US" sz="1150" dirty="0"/>
           </a:p>
@@ -7779,7 +7779,7 @@
                 <a:ea typeface="Cambria" pitchFamily="34" charset="-122"/>
                 <a:cs typeface="Cambria" pitchFamily="34" charset="-120"/>
               </a:rPr>
-              <a:t>500 000</a:t>
+              <a:t>26–40 min</a:t>
             </a:r>
             <a:endParaRPr lang="en-US" sz="2600" dirty="0"/>
           </a:p>
@@ -7818,7 +7818,7 @@
                 <a:ea typeface="Calibri" pitchFamily="34" charset="-122"/>
                 <a:cs typeface="Calibri" pitchFamily="34" charset="-120"/>
               </a:rPr>
-              <a:t>Recherchés, en FCFA</a:t>
+              <a:t>Documentaire + capsules</a:t>
             </a:r>
             <a:endParaRPr lang="en-US" sz="1150" dirty="0"/>
           </a:p>
@@ -7884,7 +7884,7 @@
                 <a:ea typeface="Cambria" pitchFamily="34" charset="-122"/>
                 <a:cs typeface="Cambria" pitchFamily="34" charset="-120"/>
               </a:rPr>
-              <a:t>26–40 min</a:t>
+              <a:t>Mars 2027</a:t>
             </a:r>
             <a:endParaRPr lang="en-US" sz="2600" dirty="0"/>
           </a:p>
@@ -7923,7 +7923,7 @@
                 <a:ea typeface="Calibri" pitchFamily="34" charset="-122"/>
                 <a:cs typeface="Calibri" pitchFamily="34" charset="-120"/>
               </a:rPr>
-              <a:t>Documentaire + capsules</a:t>
+              <a:t>Livraison des masters</a:t>
             </a:r>
             <a:endParaRPr lang="en-US" sz="1150" dirty="0"/>
           </a:p>

</xml_diff>

<commit_message>
Ajoute le PDF paysage de la presentation
Export 13,333 x 7,5 pouces des 14 planches, pour un rendu identique sur
telephone et en piece jointe : l'apercu de l'app Fichiers d'iOS melange
les planches et n'affiche pas le graphique natif.

Remplace aussi les contours d'epaisseur nulle par une absence explicite
de contour, mieux interpretee par les moteurs de rendu legers.

Co-Authored-By: Claude Opus 5 <noreply@anthropic.com>
Claude-Session: https://claude.ai/code/session_01Sk2VkMjAsq94LgCw4mRKek
</commit_message>
<xml_diff>
--- a/public/documents/presentation-salaatu-alaa-nabii.pptx
+++ b/public/documents/presentation-salaatu-alaa-nabii.pptx
@@ -7948,12 +7948,7 @@
           <a:solidFill>
             <a:srgbClr val="082F22"/>
           </a:solidFill>
-          <a:ln w="12700">
-            <a:solidFill>
-              <a:srgbClr val="082F22"/>
-            </a:solidFill>
-            <a:prstDash val="solid"/>
-          </a:ln>
+          <a:ln/>
         </p:spPr>
       </p:sp>
       <p:sp>
@@ -8261,12 +8256,7 @@
           <a:solidFill>
             <a:srgbClr val="B8860B"/>
           </a:solidFill>
-          <a:ln w="12700">
-            <a:solidFill>
-              <a:srgbClr val="B8860B"/>
-            </a:solidFill>
-            <a:prstDash val="solid"/>
-          </a:ln>
+          <a:ln/>
         </p:spPr>
       </p:sp>
       <p:sp>
@@ -8461,12 +8451,7 @@
           <a:solidFill>
             <a:srgbClr val="B8860B"/>
           </a:solidFill>
-          <a:ln w="12700">
-            <a:solidFill>
-              <a:srgbClr val="B8860B"/>
-            </a:solidFill>
-            <a:prstDash val="solid"/>
-          </a:ln>
+          <a:ln/>
         </p:spPr>
       </p:sp>
       <p:sp>
@@ -8661,12 +8646,7 @@
           <a:solidFill>
             <a:srgbClr val="B8860B"/>
           </a:solidFill>
-          <a:ln w="12700">
-            <a:solidFill>
-              <a:srgbClr val="B8860B"/>
-            </a:solidFill>
-            <a:prstDash val="solid"/>
-          </a:ln>
+          <a:ln/>
         </p:spPr>
       </p:sp>
       <p:sp>
@@ -9542,12 +9522,7 @@
           <a:solidFill>
             <a:srgbClr val="D4AF37"/>
           </a:solidFill>
-          <a:ln w="12700">
-            <a:solidFill>
-              <a:srgbClr val="D4AF37"/>
-            </a:solidFill>
-            <a:prstDash val="solid"/>
-          </a:ln>
+          <a:ln/>
         </p:spPr>
       </p:sp>
       <p:sp>
@@ -9648,12 +9623,7 @@
           <a:solidFill>
             <a:srgbClr val="D4AF37"/>
           </a:solidFill>
-          <a:ln w="12700">
-            <a:solidFill>
-              <a:srgbClr val="D4AF37"/>
-            </a:solidFill>
-            <a:prstDash val="solid"/>
-          </a:ln>
+          <a:ln/>
         </p:spPr>
       </p:sp>
       <p:sp>
@@ -9754,12 +9724,7 @@
           <a:solidFill>
             <a:srgbClr val="D4AF37"/>
           </a:solidFill>
-          <a:ln w="12700">
-            <a:solidFill>
-              <a:srgbClr val="D4AF37"/>
-            </a:solidFill>
-            <a:prstDash val="solid"/>
-          </a:ln>
+          <a:ln/>
         </p:spPr>
       </p:sp>
       <p:sp>
@@ -9860,12 +9825,7 @@
           <a:solidFill>
             <a:srgbClr val="D4AF37"/>
           </a:solidFill>
-          <a:ln w="12700">
-            <a:solidFill>
-              <a:srgbClr val="D4AF37"/>
-            </a:solidFill>
-            <a:prstDash val="solid"/>
-          </a:ln>
+          <a:ln/>
         </p:spPr>
       </p:sp>
       <p:sp>
@@ -9966,12 +9926,7 @@
           <a:solidFill>
             <a:srgbClr val="D4AF37"/>
           </a:solidFill>
-          <a:ln w="12700">
-            <a:solidFill>
-              <a:srgbClr val="D4AF37"/>
-            </a:solidFill>
-            <a:prstDash val="solid"/>
-          </a:ln>
+          <a:ln/>
         </p:spPr>
       </p:sp>
       <p:sp>
@@ -10237,12 +10192,7 @@
           <a:solidFill>
             <a:srgbClr val="B8860B"/>
           </a:solidFill>
-          <a:ln w="12700">
-            <a:solidFill>
-              <a:srgbClr val="B8860B"/>
-            </a:solidFill>
-            <a:prstDash val="solid"/>
-          </a:ln>
+          <a:ln/>
         </p:spPr>
       </p:sp>
       <p:sp>
@@ -10437,12 +10387,7 @@
           <a:solidFill>
             <a:srgbClr val="B8860B"/>
           </a:solidFill>
-          <a:ln w="12700">
-            <a:solidFill>
-              <a:srgbClr val="B8860B"/>
-            </a:solidFill>
-            <a:prstDash val="solid"/>
-          </a:ln>
+          <a:ln/>
         </p:spPr>
       </p:sp>
       <p:sp>
@@ -10637,12 +10582,7 @@
           <a:solidFill>
             <a:srgbClr val="B8860B"/>
           </a:solidFill>
-          <a:ln w="12700">
-            <a:solidFill>
-              <a:srgbClr val="B8860B"/>
-            </a:solidFill>
-            <a:prstDash val="solid"/>
-          </a:ln>
+          <a:ln/>
         </p:spPr>
       </p:sp>
       <p:sp>
@@ -10837,12 +10777,7 @@
           <a:solidFill>
             <a:srgbClr val="B8860B"/>
           </a:solidFill>
-          <a:ln w="12700">
-            <a:solidFill>
-              <a:srgbClr val="B8860B"/>
-            </a:solidFill>
-            <a:prstDash val="solid"/>
-          </a:ln>
+          <a:ln/>
         </p:spPr>
       </p:sp>
       <p:sp>
@@ -11815,12 +11750,7 @@
           <a:solidFill>
             <a:srgbClr val="082F22"/>
           </a:solidFill>
-          <a:ln w="12700">
-            <a:solidFill>
-              <a:srgbClr val="082F22"/>
-            </a:solidFill>
-            <a:prstDash val="solid"/>
-          </a:ln>
+          <a:ln/>
         </p:spPr>
       </p:sp>
       <p:sp>
@@ -12155,12 +12085,7 @@
           <a:solidFill>
             <a:srgbClr val="B8860B"/>
           </a:solidFill>
-          <a:ln w="12700">
-            <a:solidFill>
-              <a:srgbClr val="B8860B"/>
-            </a:solidFill>
-            <a:prstDash val="solid"/>
-          </a:ln>
+          <a:ln/>
         </p:spPr>
       </p:sp>
       <p:sp>
@@ -12366,12 +12291,7 @@
           <a:solidFill>
             <a:srgbClr val="B8860B"/>
           </a:solidFill>
-          <a:ln w="12700">
-            <a:solidFill>
-              <a:srgbClr val="B8860B"/>
-            </a:solidFill>
-            <a:prstDash val="solid"/>
-          </a:ln>
+          <a:ln/>
         </p:spPr>
       </p:sp>
       <p:sp>
@@ -12577,12 +12497,7 @@
           <a:solidFill>
             <a:srgbClr val="B8860B"/>
           </a:solidFill>
-          <a:ln w="12700">
-            <a:solidFill>
-              <a:srgbClr val="B8860B"/>
-            </a:solidFill>
-            <a:prstDash val="solid"/>
-          </a:ln>
+          <a:ln/>
         </p:spPr>
       </p:sp>
       <p:sp>
@@ -12788,12 +12703,7 @@
           <a:solidFill>
             <a:srgbClr val="B8860B"/>
           </a:solidFill>
-          <a:ln w="12700">
-            <a:solidFill>
-              <a:srgbClr val="B8860B"/>
-            </a:solidFill>
-            <a:prstDash val="solid"/>
-          </a:ln>
+          <a:ln/>
         </p:spPr>
       </p:sp>
       <p:sp>
@@ -12999,12 +12909,7 @@
           <a:solidFill>
             <a:srgbClr val="B8860B"/>
           </a:solidFill>
-          <a:ln w="12700">
-            <a:solidFill>
-              <a:srgbClr val="B8860B"/>
-            </a:solidFill>
-            <a:prstDash val="solid"/>
-          </a:ln>
+          <a:ln/>
         </p:spPr>
       </p:sp>
       <p:sp>
@@ -13359,12 +13264,7 @@
           <a:solidFill>
             <a:srgbClr val="D4AF37"/>
           </a:solidFill>
-          <a:ln w="12700">
-            <a:solidFill>
-              <a:srgbClr val="D4AF37"/>
-            </a:solidFill>
-            <a:prstDash val="solid"/>
-          </a:ln>
+          <a:ln/>
         </p:spPr>
       </p:sp>
       <p:sp>
@@ -13531,12 +13431,7 @@
           <a:solidFill>
             <a:srgbClr val="B8860B"/>
           </a:solidFill>
-          <a:ln w="12700">
-            <a:solidFill>
-              <a:srgbClr val="B8860B"/>
-            </a:solidFill>
-            <a:prstDash val="solid"/>
-          </a:ln>
+          <a:ln/>
         </p:spPr>
       </p:sp>
       <p:sp>
@@ -13703,12 +13598,7 @@
           <a:solidFill>
             <a:srgbClr val="B8860B"/>
           </a:solidFill>
-          <a:ln w="12700">
-            <a:solidFill>
-              <a:srgbClr val="B8860B"/>
-            </a:solidFill>
-            <a:prstDash val="solid"/>
-          </a:ln>
+          <a:ln/>
         </p:spPr>
       </p:sp>
       <p:sp>
@@ -13875,12 +13765,7 @@
           <a:solidFill>
             <a:srgbClr val="B8860B"/>
           </a:solidFill>
-          <a:ln w="12700">
-            <a:solidFill>
-              <a:srgbClr val="B8860B"/>
-            </a:solidFill>
-            <a:prstDash val="solid"/>
-          </a:ln>
+          <a:ln/>
         </p:spPr>
       </p:sp>
       <p:sp>

</xml_diff>